<commit_message>
Balance the process slide and export the PDF from PowerPoint
PowerPoint's automation started working again, so the process slide's cards
could finally be centred and checked, and the PDF re-exported properly: its
pages now carry real text in embedded Arial, Calibri and Courier New subsets
instead of 120 DPI images, in a third less space.

Co-Authored-By: Claude Opus 5 <noreply@anthropic.com>
</commit_message>
<xml_diff>
--- a/Myat-Htoo-Khaing-Portfolio.pptx
+++ b/Myat-Htoo-Khaing-Portfolio.pptx
@@ -121,14 +121,14 @@
   <p:extLst>
     <p:ext uri="{521415D9-36F7-43E2-AB2F-B90AF26B5E84}">
       <p14:sectionLst xmlns:p14="http://schemas.microsoft.com/office/powerpoint/2010/main">
-        <p14:section name="Intro" id="{e682a19e-4c6a-dfa4-7032-f51b4acb47b4}">
+        <p14:section name="Intro" id="{31c4973c-1b60-e14c-188e-0fee21ba1d7a}">
           <p14:sldIdLst>
             <p14:sldId id="256"/>
             <p14:sldId id="257"/>
             <p14:sldId id="258"/>
           </p14:sldIdLst>
         </p14:section>
-        <p14:section name="Selected work" id="{b3da9fd9-fd4c-dcab-439e-48c8d7e3e1ff}">
+        <p14:section name="Selected work" id="{cd46371c-d8ad-cff6-ae4d-31fd3fdea806}">
           <p14:sldIdLst>
             <p14:sldId id="259"/>
             <p14:sldId id="260"/>
@@ -139,19 +139,19 @@
             <p14:sldId id="265"/>
           </p14:sldIdLst>
         </p14:section>
-        <p14:section name="How I work" id="{dfc761c2-4a7f-0dd4-3a74-e3260b5796c8}">
+        <p14:section name="How I work" id="{eb9d8624-fbe9-d47b-b595-b37bfe2e6dd8}">
           <p14:sldIdLst>
             <p14:sldId id="266"/>
           </p14:sldIdLst>
         </p14:section>
-        <p14:section name="Background" id="{983eb8f3-34e4-813b-5b13-4bbe8897c7e2}">
+        <p14:section name="Background" id="{41e6d856-393d-926b-8dd1-e63ba5d1f25c}">
           <p14:sldIdLst>
             <p14:sldId id="267"/>
             <p14:sldId id="268"/>
             <p14:sldId id="269"/>
           </p14:sldIdLst>
         </p14:section>
-        <p14:section name="Contact" id="{1667bf25-0f21-c71c-4a28-0273dbe8ce73}">
+        <p14:section name="Contact" id="{dc16477c-beca-b2e0-92f1-a7b68e200254}">
           <p14:sldIdLst>
             <p14:sldId id="270"/>
           </p14:sldIdLst>

</xml_diff>